<commit_message>
Update presentation and add temp file
Replace binary project_update.pptx with an updated version. Also adds an Office temporary/lock file (~$project_update.pptx) — likely an autogenerated editor temp file that can be ignored or added to .gitignore to avoid committing in the future.
</commit_message>
<xml_diff>
--- a/project_update.pptx
+++ b/project_update.pptx
@@ -5,11 +5,14 @@
     <p:sldMasterId id="2147483672" r:id="rId1"/>
   </p:sldMasterIdLst>
   <p:notesMasterIdLst>
-    <p:notesMasterId r:id="rId4"/>
+    <p:notesMasterId r:id="rId7"/>
   </p:notesMasterIdLst>
   <p:sldIdLst>
     <p:sldId id="275" r:id="rId2"/>
-    <p:sldId id="277" r:id="rId3"/>
+    <p:sldId id="312" r:id="rId3"/>
+    <p:sldId id="327" r:id="rId4"/>
+    <p:sldId id="334" r:id="rId5"/>
+    <p:sldId id="332" r:id="rId6"/>
   </p:sldIdLst>
   <p:sldSz cx="12192000" cy="6858000"/>
   <p:notesSz cx="6858000" cy="9144000"/>
@@ -4073,17 +4076,41 @@
         </p:nvSpPr>
         <p:spPr>
           <a:xfrm>
-            <a:off x="838200" y="1473200"/>
-            <a:ext cx="10515600" cy="812800"/>
+            <a:off x="838200" y="1397000"/>
+            <a:ext cx="10515600" cy="711200"/>
           </a:xfrm>
         </p:spPr>
         <p:txBody>
-          <a:bodyPr/>
+          <a:bodyPr anchor="t" anchorCtr="0"/>
           <a:lstStyle/>
           <a:p>
             <a:pPr algn="l">
               <a:buNone/>
             </a:pPr>
+            <a:r>
+              <a:rPr lang="en-US" sz="3200" b="1" dirty="0">
+                <a:solidFill>
+                  <a:srgbClr val="00396B"/>
+                </a:solidFill>
+              </a:rPr>
+              <a:t>Project</a:t>
+            </a:r>
+            <a:r>
+              <a:rPr lang="zh-CN" altLang="en-US" sz="3200" b="1" dirty="0">
+                <a:solidFill>
+                  <a:srgbClr val="00396B"/>
+                </a:solidFill>
+              </a:rPr>
+              <a:t> </a:t>
+            </a:r>
+            <a:r>
+              <a:rPr lang="en-US" altLang="zh-CN" sz="3200" b="1" dirty="0">
+                <a:solidFill>
+                  <a:srgbClr val="00396B"/>
+                </a:solidFill>
+              </a:rPr>
+              <a:t>Overview</a:t>
+            </a:r>
             <a:endParaRPr lang="en-US" sz="3200" b="1" dirty="0">
               <a:solidFill>
                 <a:srgbClr val="00396B"/>
@@ -4121,11 +4148,7 @@
             <a:pPr>
               <a:buNone/>
             </a:pPr>
-            <a:endParaRPr lang="en-US" sz="2000" dirty="0">
-              <a:solidFill>
-                <a:srgbClr val="1A1A1A"/>
-              </a:solidFill>
-            </a:endParaRPr>
+            <a:endParaRPr lang="en-US" sz="1200" dirty="0"/>
           </a:p>
         </p:txBody>
       </p:sp>
@@ -4185,7 +4208,7 @@
         </p:nvSpPr>
         <p:spPr>
           <a:xfrm>
-            <a:off x="838200" y="2311400"/>
+            <a:off x="838200" y="2209800"/>
             <a:ext cx="1524000" cy="76200"/>
           </a:xfrm>
           <a:prstGeom prst="rect">
@@ -4255,10 +4278,2214 @@
           </a:prstGeom>
         </p:spPr>
       </p:pic>
+      <p:sp>
+        <p:nvSpPr>
+          <p:cNvPr id="20" name="Card Header 20"/>
+          <p:cNvSpPr/>
+          <p:nvPr/>
+        </p:nvSpPr>
+        <p:spPr>
+          <a:xfrm>
+            <a:off x="838200" y="2489200"/>
+            <a:ext cx="5080000" cy="584200"/>
+          </a:xfrm>
+          <a:prstGeom prst="round2SameRect">
+            <a:avLst>
+              <a:gd name="adj1" fmla="val 12000"/>
+              <a:gd name="adj2" fmla="val 0"/>
+            </a:avLst>
+          </a:prstGeom>
+          <a:solidFill>
+            <a:srgbClr val="00396B"/>
+          </a:solidFill>
+          <a:ln>
+            <a:noFill/>
+          </a:ln>
+        </p:spPr>
+        <p:txBody>
+          <a:bodyPr wrap="square" lIns="203200" tIns="0" rIns="203200" bIns="0" anchor="ctr"/>
+          <a:lstStyle/>
+          <a:p>
+            <a:pPr algn="l">
+              <a:buNone/>
+            </a:pPr>
+            <a:r>
+              <a:rPr lang="en-US" sz="2000" b="1" dirty="0">
+                <a:solidFill>
+                  <a:srgbClr val="FFFFFF"/>
+                </a:solidFill>
+              </a:rPr>
+              <a:t>Research Direction</a:t>
+            </a:r>
+          </a:p>
+        </p:txBody>
+      </p:sp>
+      <p:sp>
+        <p:nvSpPr>
+          <p:cNvPr id="21" name="Card Body 20"/>
+          <p:cNvSpPr/>
+          <p:nvPr/>
+        </p:nvSpPr>
+        <p:spPr>
+          <a:xfrm>
+            <a:off x="838200" y="3073400"/>
+            <a:ext cx="5080000" cy="3175000"/>
+          </a:xfrm>
+          <a:prstGeom prst="round2SameRect">
+            <a:avLst>
+              <a:gd name="adj1" fmla="val 0"/>
+              <a:gd name="adj2" fmla="val 12000"/>
+            </a:avLst>
+          </a:prstGeom>
+          <a:solidFill>
+            <a:srgbClr val="EEF2F6"/>
+          </a:solidFill>
+          <a:ln>
+            <a:noFill/>
+          </a:ln>
+        </p:spPr>
+        <p:txBody>
+          <a:bodyPr wrap="square" lIns="228600" tIns="177800" rIns="228600" bIns="177800" anchor="t"/>
+          <a:lstStyle/>
+          <a:p>
+            <a:pPr marL="0" indent="0" algn="l">
+              <a:spcAft>
+                <a:spcPts val="400"/>
+              </a:spcAft>
+              <a:buNone/>
+            </a:pPr>
+            <a:r>
+              <a:rPr lang="en-US" sz="1700" b="1" dirty="0">
+                <a:solidFill>
+                  <a:srgbClr val="1A1A1A"/>
+                </a:solidFill>
+              </a:rPr>
+              <a:t>LLM-based multi-agent system</a:t>
+            </a:r>
+          </a:p>
+          <a:p>
+            <a:pPr marL="254000" indent="-254000" algn="l">
+              <a:spcBef>
+                <a:spcPts val="300"/>
+              </a:spcBef>
+              <a:spcAft>
+                <a:spcPts val="300"/>
+              </a:spcAft>
+              <a:buFont typeface="Arial"/>
+              <a:buChar char="•"/>
+            </a:pPr>
+            <a:r>
+              <a:rPr lang="en-US" sz="1500" b="1" dirty="0">
+                <a:solidFill>
+                  <a:srgbClr val="1A1A1A"/>
+                </a:solidFill>
+              </a:rPr>
+              <a:t>Agent harness: </a:t>
+            </a:r>
+            <a:r>
+              <a:rPr lang="en-US" sz="1500" dirty="0">
+                <a:solidFill>
+                  <a:srgbClr val="1A1A1A"/>
+                </a:solidFill>
+              </a:rPr>
+              <a:t>scaffolding around the LLM that manages the reasoning loop, tool invocation, and state across turns</a:t>
+            </a:r>
+          </a:p>
+          <a:p>
+            <a:pPr marL="254000" indent="-254000" algn="l">
+              <a:spcBef>
+                <a:spcPts val="300"/>
+              </a:spcBef>
+              <a:spcAft>
+                <a:spcPts val="300"/>
+              </a:spcAft>
+              <a:buFont typeface="Arial"/>
+              <a:buChar char="•"/>
+            </a:pPr>
+            <a:r>
+              <a:rPr lang="en-US" sz="1500" b="1" dirty="0">
+                <a:solidFill>
+                  <a:srgbClr val="1A1A1A"/>
+                </a:solidFill>
+              </a:rPr>
+              <a:t>Decentralized coordination: </a:t>
+            </a:r>
+            <a:r>
+              <a:rPr lang="en-US" sz="1500" dirty="0">
+                <a:solidFill>
+                  <a:srgbClr val="1A1A1A"/>
+                </a:solidFill>
+              </a:rPr>
+              <a:t>agents self-organize and reach consensus without a central orchestrator</a:t>
+            </a:r>
+          </a:p>
+        </p:txBody>
+      </p:sp>
+      <p:sp>
+        <p:nvSpPr>
+          <p:cNvPr id="30" name="Card Header 30"/>
+          <p:cNvSpPr/>
+          <p:nvPr/>
+        </p:nvSpPr>
+        <p:spPr>
+          <a:xfrm>
+            <a:off x="6273800" y="2489200"/>
+            <a:ext cx="5080000" cy="584200"/>
+          </a:xfrm>
+          <a:prstGeom prst="round2SameRect">
+            <a:avLst>
+              <a:gd name="adj1" fmla="val 12000"/>
+              <a:gd name="adj2" fmla="val 0"/>
+            </a:avLst>
+          </a:prstGeom>
+          <a:solidFill>
+            <a:srgbClr val="00396B"/>
+          </a:solidFill>
+          <a:ln>
+            <a:noFill/>
+          </a:ln>
+        </p:spPr>
+        <p:txBody>
+          <a:bodyPr wrap="square" lIns="203200" tIns="0" rIns="203200" bIns="0" anchor="ctr"/>
+          <a:lstStyle/>
+          <a:p>
+            <a:pPr algn="l">
+              <a:buNone/>
+            </a:pPr>
+            <a:r>
+              <a:rPr lang="en-US" sz="2000" b="1" dirty="0">
+                <a:solidFill>
+                  <a:srgbClr val="FFFFFF"/>
+                </a:solidFill>
+              </a:rPr>
+              <a:t>Goals</a:t>
+            </a:r>
+          </a:p>
+        </p:txBody>
+      </p:sp>
+      <p:sp>
+        <p:nvSpPr>
+          <p:cNvPr id="31" name="Card Body 30"/>
+          <p:cNvSpPr/>
+          <p:nvPr/>
+        </p:nvSpPr>
+        <p:spPr>
+          <a:xfrm>
+            <a:off x="6273800" y="3073400"/>
+            <a:ext cx="5080000" cy="3175000"/>
+          </a:xfrm>
+          <a:prstGeom prst="round2SameRect">
+            <a:avLst>
+              <a:gd name="adj1" fmla="val 0"/>
+              <a:gd name="adj2" fmla="val 12000"/>
+            </a:avLst>
+          </a:prstGeom>
+          <a:solidFill>
+            <a:srgbClr val="EEF2F6"/>
+          </a:solidFill>
+          <a:ln>
+            <a:noFill/>
+          </a:ln>
+        </p:spPr>
+        <p:txBody>
+          <a:bodyPr wrap="square" lIns="228600" tIns="177800" rIns="228600" bIns="177800" anchor="t"/>
+          <a:lstStyle/>
+          <a:p>
+            <a:pPr marL="254000" indent="-254000" algn="l">
+              <a:spcBef>
+                <a:spcPts val="300"/>
+              </a:spcBef>
+              <a:spcAft>
+                <a:spcPts val="300"/>
+              </a:spcAft>
+              <a:buFont typeface="Arial"/>
+              <a:buChar char="•"/>
+            </a:pPr>
+            <a:r>
+              <a:rPr lang="en-US" sz="1500" b="1" dirty="0">
+                <a:solidFill>
+                  <a:srgbClr val="1A1A1A"/>
+                </a:solidFill>
+              </a:rPr>
+              <a:t>Effective agent workflows: </a:t>
+            </a:r>
+            <a:r>
+              <a:rPr lang="en-US" sz="1500" dirty="0">
+                <a:solidFill>
+                  <a:srgbClr val="1A1A1A"/>
+                </a:solidFill>
+              </a:rPr>
+              <a:t>robust task decomposition and recovery that hold up on long-horizon tasks</a:t>
+            </a:r>
+          </a:p>
+          <a:p>
+            <a:pPr marL="254000" indent="-254000" algn="l">
+              <a:spcBef>
+                <a:spcPts val="300"/>
+              </a:spcBef>
+              <a:spcAft>
+                <a:spcPts val="300"/>
+              </a:spcAft>
+              <a:buFont typeface="Arial"/>
+              <a:buChar char="•"/>
+            </a:pPr>
+            <a:r>
+              <a:rPr lang="en-US" sz="1500" b="1" dirty="0">
+                <a:solidFill>
+                  <a:srgbClr val="1A1A1A"/>
+                </a:solidFill>
+              </a:rPr>
+              <a:t>Token efficiency: </a:t>
+            </a:r>
+            <a:r>
+              <a:rPr lang="en-US" sz="1500" dirty="0">
+                <a:solidFill>
+                  <a:srgbClr val="1A1A1A"/>
+                </a:solidFill>
+              </a:rPr>
+              <a:t>cut inter-agent communication and context overhead without losing accuracy</a:t>
+            </a:r>
+          </a:p>
+          <a:p>
+            <a:pPr marL="254000" indent="-254000" algn="l">
+              <a:spcBef>
+                <a:spcPts val="300"/>
+              </a:spcBef>
+              <a:spcAft>
+                <a:spcPts val="300"/>
+              </a:spcAft>
+              <a:buFont typeface="Arial"/>
+              <a:buChar char="•"/>
+            </a:pPr>
+            <a:r>
+              <a:rPr lang="en-US" sz="1500" b="1" dirty="0">
+                <a:solidFill>
+                  <a:srgbClr val="1A1A1A"/>
+                </a:solidFill>
+              </a:rPr>
+              <a:t>Research output: </a:t>
+            </a:r>
+            <a:r>
+              <a:rPr lang="en-US" sz="1500" dirty="0">
+                <a:solidFill>
+                  <a:srgbClr val="1A1A1A"/>
+                </a:solidFill>
+              </a:rPr>
+              <a:t>identify challenging, high-impact problems, solve them, and consolidate the findings into a paper submission</a:t>
+            </a:r>
+          </a:p>
+        </p:txBody>
+      </p:sp>
+      <p:sp>
+        <p:nvSpPr>
+          <p:cNvPr id="10" name="Footer Name">
+            <a:extLst>
+              <a:ext uri="{FF2B5EF4-FFF2-40B4-BE49-F238E27FC236}">
+                <a16:creationId xmlns:a16="http://schemas.microsoft.com/office/drawing/2014/main" id="{C86A6180-15B8-B344-BE74-A13E0788843F}"/>
+              </a:ext>
+            </a:extLst>
+          </p:cNvPr>
+          <p:cNvSpPr txBox="1"/>
+          <p:nvPr/>
+        </p:nvSpPr>
+        <p:spPr>
+          <a:xfrm>
+            <a:off x="838200" y="6350000"/>
+            <a:ext cx="5080000" cy="508000"/>
+          </a:xfrm>
+          <a:prstGeom prst="rect">
+            <a:avLst/>
+          </a:prstGeom>
+          <a:noFill/>
+        </p:spPr>
+        <p:txBody>
+          <a:bodyPr vertOverflow="overflow" vert="horz" wrap="none" rtlCol="0" anchor="ctr" anchorCtr="0">
+            <a:noAutofit/>
+          </a:bodyPr>
+          <a:lstStyle/>
+          <a:p>
+            <a:pPr algn="l">
+              <a:buNone/>
+            </a:pPr>
+            <a:r>
+              <a:rPr lang="en-US" sz="1400" b="1" spc="200" dirty="0">
+                <a:solidFill>
+                  <a:srgbClr val="FFFFFF"/>
+                </a:solidFill>
+              </a:rPr>
+              <a:t>Quan Wei</a:t>
+            </a:r>
+            <a:r>
+              <a:rPr lang="en-US" sz="1400" b="1" spc="200" dirty="0">
+                <a:solidFill>
+                  <a:srgbClr val="9AA7B5"/>
+                </a:solidFill>
+              </a:rPr>
+              <a:t>   |   </a:t>
+            </a:r>
+            <a:r>
+              <a:rPr lang="en-US" sz="1400" b="1" spc="200" dirty="0">
+                <a:solidFill>
+                  <a:srgbClr val="FFFFFF"/>
+                </a:solidFill>
+              </a:rPr>
+              <a:t>WEEK 1</a:t>
+            </a:r>
+          </a:p>
+        </p:txBody>
+      </p:sp>
     </p:spTree>
     <p:extLst>
       <p:ext uri="{BB962C8B-B14F-4D97-AF65-F5344CB8AC3E}">
-        <p14:creationId xmlns:p14="http://schemas.microsoft.com/office/powerpoint/2010/main" val="659560431"/>
+        <p14:creationId xmlns:p14="http://schemas.microsoft.com/office/powerpoint/2010/main" val="2649299185"/>
+      </p:ext>
+    </p:extLst>
+  </p:cSld>
+  <p:clrMapOvr>
+    <a:masterClrMapping/>
+  </p:clrMapOvr>
+</p:sld>
+</file>
+
+<file path=ppt/slides/slide3.xml><?xml version="1.0" encoding="utf-8"?>
+<p:sld xmlns:a="http://schemas.openxmlformats.org/drawingml/2006/main" xmlns:r="http://schemas.openxmlformats.org/officeDocument/2006/relationships" xmlns:p="http://schemas.openxmlformats.org/presentationml/2006/main">
+  <p:cSld>
+    <p:spTree>
+      <p:nvGrpSpPr>
+        <p:cNvPr id="1" name="">
+          <a:extLst>
+            <a:ext uri="{FF2B5EF4-FFF2-40B4-BE49-F238E27FC236}">
+              <a16:creationId xmlns:a16="http://schemas.microsoft.com/office/drawing/2014/main" id="{984EEBEB-8015-2366-C980-540CC20E1FE2}"/>
+            </a:ext>
+          </a:extLst>
+        </p:cNvPr>
+        <p:cNvGrpSpPr/>
+        <p:nvPr/>
+      </p:nvGrpSpPr>
+      <p:grpSpPr>
+        <a:xfrm>
+          <a:off x="0" y="0"/>
+          <a:ext cx="0" cy="0"/>
+          <a:chOff x="0" y="0"/>
+          <a:chExt cx="0" cy="0"/>
+        </a:xfrm>
+      </p:grpSpPr>
+      <p:sp>
+        <p:nvSpPr>
+          <p:cNvPr id="5" name="Footer Bar">
+            <a:extLst>
+              <a:ext uri="{FF2B5EF4-FFF2-40B4-BE49-F238E27FC236}">
+                <a16:creationId xmlns:a16="http://schemas.microsoft.com/office/drawing/2014/main" id="{3C4C11B8-CC0E-5DAA-BC2A-D74FC9415AF1}"/>
+              </a:ext>
+            </a:extLst>
+          </p:cNvPr>
+          <p:cNvSpPr/>
+          <p:nvPr/>
+        </p:nvSpPr>
+        <p:spPr>
+          <a:xfrm>
+            <a:off x="0" y="6350000"/>
+            <a:ext cx="12192000" cy="508000"/>
+          </a:xfrm>
+          <a:prstGeom prst="rect">
+            <a:avLst/>
+          </a:prstGeom>
+          <a:solidFill>
+            <a:srgbClr val="00396B"/>
+          </a:solidFill>
+          <a:ln w="12700" cap="flat" cmpd="sng" algn="ctr">
+            <a:noFill/>
+            <a:prstDash val="solid"/>
+            <a:miter lim="800000"/>
+          </a:ln>
+        </p:spPr>
+        <p:style>
+          <a:lnRef idx="2">
+            <a:schemeClr val="accent1">
+              <a:shade val="15000"/>
+            </a:schemeClr>
+          </a:lnRef>
+          <a:fillRef idx="1">
+            <a:schemeClr val="accent1"/>
+          </a:fillRef>
+          <a:effectRef idx="0">
+            <a:schemeClr val="accent1"/>
+          </a:effectRef>
+          <a:fontRef idx="minor">
+            <a:schemeClr val="lt1"/>
+          </a:fontRef>
+        </p:style>
+        <p:txBody>
+          <a:bodyPr vertOverflow="clip" horzOverflow="clip" rtlCol="0" anchor="t"/>
+          <a:lstStyle/>
+          <a:p>
+            <a:pPr algn="l"/>
+            <a:endParaRPr lang="en-CN"/>
+          </a:p>
+        </p:txBody>
+      </p:sp>
+      <p:sp>
+        <p:nvSpPr>
+          <p:cNvPr id="2" name="Title 1">
+            <a:extLst>
+              <a:ext uri="{FF2B5EF4-FFF2-40B4-BE49-F238E27FC236}">
+                <a16:creationId xmlns:a16="http://schemas.microsoft.com/office/drawing/2014/main" id="{EAF7C45E-9EB4-C736-A453-7F982B2067D5}"/>
+              </a:ext>
+            </a:extLst>
+          </p:cNvPr>
+          <p:cNvSpPr>
+            <a:spLocks noGrp="1"/>
+          </p:cNvSpPr>
+          <p:nvPr>
+            <p:ph type="title"/>
+          </p:nvPr>
+        </p:nvSpPr>
+        <p:spPr>
+          <a:xfrm>
+            <a:off x="838200" y="1397000"/>
+            <a:ext cx="10515600" cy="711200"/>
+          </a:xfrm>
+        </p:spPr>
+        <p:txBody>
+          <a:bodyPr anchor="t" anchorCtr="0"/>
+          <a:lstStyle/>
+          <a:p>
+            <a:r>
+              <a:rPr lang="en-US" altLang="zh-CN" sz="3200" b="1" dirty="0">
+                <a:solidFill>
+                  <a:srgbClr val="00396B"/>
+                </a:solidFill>
+              </a:rPr>
+              <a:t>Project</a:t>
+            </a:r>
+            <a:r>
+              <a:rPr lang="zh-CN" altLang="en-US" sz="3200" b="1" dirty="0">
+                <a:solidFill>
+                  <a:srgbClr val="00396B"/>
+                </a:solidFill>
+              </a:rPr>
+              <a:t> </a:t>
+            </a:r>
+            <a:r>
+              <a:rPr lang="en-US" sz="3200" b="1" dirty="0">
+                <a:solidFill>
+                  <a:srgbClr val="00396B"/>
+                </a:solidFill>
+              </a:rPr>
+              <a:t>Proposal</a:t>
+            </a:r>
+          </a:p>
+        </p:txBody>
+      </p:sp>
+      <p:sp>
+        <p:nvSpPr>
+          <p:cNvPr id="3" name="Content Placeholder 2">
+            <a:extLst>
+              <a:ext uri="{FF2B5EF4-FFF2-40B4-BE49-F238E27FC236}">
+                <a16:creationId xmlns:a16="http://schemas.microsoft.com/office/drawing/2014/main" id="{013F6CFD-F019-3D66-B40F-9942631B9A30}"/>
+              </a:ext>
+            </a:extLst>
+          </p:cNvPr>
+          <p:cNvSpPr>
+            <a:spLocks noGrp="1"/>
+          </p:cNvSpPr>
+          <p:nvPr>
+            <p:ph idx="1"/>
+          </p:nvPr>
+        </p:nvSpPr>
+        <p:spPr>
+          <a:xfrm>
+            <a:off x="838200" y="2387600"/>
+            <a:ext cx="10515600" cy="457200"/>
+          </a:xfrm>
+        </p:spPr>
+        <p:txBody>
+          <a:bodyPr>
+            <a:normAutofit/>
+          </a:bodyPr>
+          <a:lstStyle/>
+          <a:p>
+            <a:pPr marL="0" indent="0" algn="l">
+              <a:spcBef>
+                <a:spcPts val="200"/>
+              </a:spcBef>
+              <a:spcAft>
+                <a:spcPts val="200"/>
+              </a:spcAft>
+              <a:buNone/>
+            </a:pPr>
+            <a:r>
+              <a:rPr lang="en-US" sz="2000" b="1" dirty="0">
+                <a:solidFill>
+                  <a:srgbClr val="00396B"/>
+                </a:solidFill>
+              </a:rPr>
+              <a:t>Large–Small Model Collaboration</a:t>
+            </a:r>
+            <a:r>
+              <a:rPr lang="en-US" sz="1600" dirty="0">
+                <a:solidFill>
+                  <a:srgbClr val="3A3A3C"/>
+                </a:solidFill>
+              </a:rPr>
+              <a:t>  —  each tier does the work it is best suited for</a:t>
+            </a:r>
+          </a:p>
+        </p:txBody>
+      </p:sp>
+      <p:sp>
+        <p:nvSpPr>
+          <p:cNvPr id="4" name="Slide Number Placeholder 3">
+            <a:extLst>
+              <a:ext uri="{FF2B5EF4-FFF2-40B4-BE49-F238E27FC236}">
+                <a16:creationId xmlns:a16="http://schemas.microsoft.com/office/drawing/2014/main" id="{EBDF33FE-E587-E27D-873C-E07E16B0A796}"/>
+              </a:ext>
+            </a:extLst>
+          </p:cNvPr>
+          <p:cNvSpPr>
+            <a:spLocks noGrp="1"/>
+          </p:cNvSpPr>
+          <p:nvPr>
+            <p:ph type="sldNum" sz="quarter" idx="12"/>
+          </p:nvPr>
+        </p:nvSpPr>
+        <p:spPr>
+          <a:xfrm>
+            <a:off x="10210800" y="6451600"/>
+            <a:ext cx="1524000" cy="304800"/>
+          </a:xfrm>
+        </p:spPr>
+        <p:txBody>
+          <a:bodyPr anchor="ctr" anchorCtr="0"/>
+          <a:lstStyle/>
+          <a:p>
+            <a:fld id="{FC0A7A6B-4B1F-5446-A3A1-99DEB5EA7F81}" type="slidenum">
+              <a:rPr lang="en-CN" smtClean="0">
+                <a:solidFill>
+                  <a:srgbClr val="9AA7B5"/>
+                </a:solidFill>
+              </a:rPr>
+              <a:t>3</a:t>
+            </a:fld>
+            <a:endParaRPr lang="en-CN">
+              <a:solidFill>
+                <a:srgbClr val="9AA7B5"/>
+              </a:solidFill>
+            </a:endParaRPr>
+          </a:p>
+        </p:txBody>
+      </p:sp>
+      <p:sp>
+        <p:nvSpPr>
+          <p:cNvPr id="6" name="Accent Rule">
+            <a:extLst>
+              <a:ext uri="{FF2B5EF4-FFF2-40B4-BE49-F238E27FC236}">
+                <a16:creationId xmlns:a16="http://schemas.microsoft.com/office/drawing/2014/main" id="{C68C517F-5ACB-7B49-135C-7434082740D8}"/>
+              </a:ext>
+            </a:extLst>
+          </p:cNvPr>
+          <p:cNvSpPr/>
+          <p:nvPr/>
+        </p:nvSpPr>
+        <p:spPr>
+          <a:xfrm>
+            <a:off x="838200" y="2209800"/>
+            <a:ext cx="1524000" cy="76200"/>
+          </a:xfrm>
+          <a:prstGeom prst="rect">
+            <a:avLst/>
+          </a:prstGeom>
+          <a:solidFill>
+            <a:srgbClr val="0073CF"/>
+          </a:solidFill>
+          <a:ln w="12700" cap="flat" cmpd="sng" algn="ctr">
+            <a:noFill/>
+            <a:prstDash val="solid"/>
+            <a:miter lim="800000"/>
+          </a:ln>
+        </p:spPr>
+        <p:style>
+          <a:lnRef idx="2">
+            <a:schemeClr val="accent1">
+              <a:shade val="15000"/>
+            </a:schemeClr>
+          </a:lnRef>
+          <a:fillRef idx="1">
+            <a:schemeClr val="accent1"/>
+          </a:fillRef>
+          <a:effectRef idx="0">
+            <a:schemeClr val="accent1"/>
+          </a:effectRef>
+          <a:fontRef idx="minor">
+            <a:schemeClr val="lt1"/>
+          </a:fontRef>
+        </p:style>
+        <p:txBody>
+          <a:bodyPr vertOverflow="clip" horzOverflow="clip" rtlCol="0" anchor="t"/>
+          <a:lstStyle/>
+          <a:p>
+            <a:pPr algn="l"/>
+            <a:endParaRPr lang="en-CN"/>
+          </a:p>
+        </p:txBody>
+      </p:sp>
+      <p:pic>
+        <p:nvPicPr>
+          <p:cNvPr id="7" name="Copied Picture 7">
+            <a:extLst>
+              <a:ext uri="{FF2B5EF4-FFF2-40B4-BE49-F238E27FC236}">
+                <a16:creationId xmlns:a16="http://schemas.microsoft.com/office/drawing/2014/main" id="{CA4B2E08-AD10-974E-24F5-613EE04D3031}"/>
+              </a:ext>
+            </a:extLst>
+          </p:cNvPr>
+          <p:cNvPicPr>
+            <a:picLocks noChangeAspect="1"/>
+          </p:cNvPicPr>
+          <p:nvPr/>
+        </p:nvPicPr>
+        <p:blipFill>
+          <a:blip r:embed="rId2"/>
+          <a:stretch>
+            <a:fillRect/>
+          </a:stretch>
+        </p:blipFill>
+        <p:spPr>
+          <a:xfrm>
+            <a:off x="838200" y="508000"/>
+            <a:ext cx="762000" cy="762000"/>
+          </a:xfrm>
+          <a:prstGeom prst="rect">
+            <a:avLst/>
+          </a:prstGeom>
+        </p:spPr>
+      </p:pic>
+      <p:sp>
+        <p:nvSpPr>
+          <p:cNvPr id="10" name="Footer Name">
+            <a:extLst>
+              <a:ext uri="{FF2B5EF4-FFF2-40B4-BE49-F238E27FC236}">
+                <a16:creationId xmlns:a16="http://schemas.microsoft.com/office/drawing/2014/main" id="{96DB3708-BCDB-4D06-A70B-E5FA88A3E60A}"/>
+              </a:ext>
+            </a:extLst>
+          </p:cNvPr>
+          <p:cNvSpPr txBox="1"/>
+          <p:nvPr/>
+        </p:nvSpPr>
+        <p:spPr>
+          <a:xfrm>
+            <a:off x="838200" y="6350000"/>
+            <a:ext cx="5080000" cy="508000"/>
+          </a:xfrm>
+          <a:prstGeom prst="rect">
+            <a:avLst/>
+          </a:prstGeom>
+          <a:noFill/>
+        </p:spPr>
+        <p:txBody>
+          <a:bodyPr vertOverflow="overflow" vert="horz" wrap="none" rtlCol="0" anchor="ctr" anchorCtr="0">
+            <a:noAutofit/>
+          </a:bodyPr>
+          <a:lstStyle/>
+          <a:p>
+            <a:pPr algn="l">
+              <a:buNone/>
+            </a:pPr>
+            <a:r>
+              <a:rPr lang="en-US" sz="1400" b="1" spc="200" dirty="0">
+                <a:solidFill>
+                  <a:srgbClr val="FFFFFF"/>
+                </a:solidFill>
+              </a:rPr>
+              <a:t>Quan Wei</a:t>
+            </a:r>
+            <a:r>
+              <a:rPr lang="en-US" sz="1400" b="1" spc="200" dirty="0">
+                <a:solidFill>
+                  <a:srgbClr val="9AA7B5"/>
+                </a:solidFill>
+              </a:rPr>
+              <a:t>   |   </a:t>
+            </a:r>
+            <a:r>
+              <a:rPr lang="en-US" sz="1400" b="1" spc="200" dirty="0">
+                <a:solidFill>
+                  <a:srgbClr val="FFFFFF"/>
+                </a:solidFill>
+              </a:rPr>
+              <a:t>WEEK 1</a:t>
+            </a:r>
+          </a:p>
+        </p:txBody>
+      </p:sp>
+      <p:graphicFrame>
+        <p:nvGraphicFramePr>
+          <p:cNvPr id="9" name="LLM SLM Table">
+            <a:extLst>
+              <a:ext uri="{FF2B5EF4-FFF2-40B4-BE49-F238E27FC236}">
+                <a16:creationId xmlns:a16="http://schemas.microsoft.com/office/drawing/2014/main" id="{29D22ECD-818E-5847-B870-BB464A49F2F4}"/>
+              </a:ext>
+            </a:extLst>
+          </p:cNvPr>
+          <p:cNvGraphicFramePr>
+            <a:graphicFrameLocks noGrp="1"/>
+          </p:cNvGraphicFramePr>
+          <p:nvPr>
+            <p:extLst>
+              <p:ext uri="{D42A27DB-BD31-4B8C-83A1-F6EECF244321}">
+                <p14:modId xmlns:p14="http://schemas.microsoft.com/office/powerpoint/2010/main" val="2998387024"/>
+              </p:ext>
+            </p:extLst>
+          </p:nvPr>
+        </p:nvGraphicFramePr>
+        <p:xfrm>
+          <a:off x="838200" y="2971800"/>
+          <a:ext cx="10515600" cy="1422400"/>
+        </p:xfrm>
+        <a:graphic>
+          <a:graphicData uri="http://schemas.openxmlformats.org/drawingml/2006/table">
+            <a:tbl>
+              <a:tblPr firstRow="1" bandRow="1">
+                <a:tableStyleId>{5C22544A-7EE6-4342-B048-85BDC9FD1C3A}</a:tableStyleId>
+              </a:tblPr>
+              <a:tblGrid>
+                <a:gridCol w="3505200">
+                  <a:extLst>
+                    <a:ext uri="{9D8B030D-6E8A-4147-A177-3AD203B41FA5}">
+                      <a16:colId xmlns:a16="http://schemas.microsoft.com/office/drawing/2014/main" val="2108653149"/>
+                    </a:ext>
+                  </a:extLst>
+                </a:gridCol>
+                <a:gridCol w="3505200">
+                  <a:extLst>
+                    <a:ext uri="{9D8B030D-6E8A-4147-A177-3AD203B41FA5}">
+                      <a16:colId xmlns:a16="http://schemas.microsoft.com/office/drawing/2014/main" val="1666027131"/>
+                    </a:ext>
+                  </a:extLst>
+                </a:gridCol>
+                <a:gridCol w="3505200">
+                  <a:extLst>
+                    <a:ext uri="{9D8B030D-6E8A-4147-A177-3AD203B41FA5}">
+                      <a16:colId xmlns:a16="http://schemas.microsoft.com/office/drawing/2014/main" val="2661020268"/>
+                    </a:ext>
+                  </a:extLst>
+                </a:gridCol>
+              </a:tblGrid>
+              <a:tr h="355600">
+                <a:tc>
+                  <a:txBody>
+                    <a:bodyPr/>
+                    <a:lstStyle/>
+                    <a:p>
+                      <a:pPr algn="l"/>
+                      <a:endParaRPr lang="en-CN" sz="1500" b="1">
+                        <a:solidFill>
+                          <a:srgbClr val="FFFFFF"/>
+                        </a:solidFill>
+                      </a:endParaRPr>
+                    </a:p>
+                  </a:txBody>
+                  <a:tcPr anchor="ctr">
+                    <a:solidFill>
+                      <a:srgbClr val="00396B"/>
+                    </a:solidFill>
+                  </a:tcPr>
+                </a:tc>
+                <a:tc>
+                  <a:txBody>
+                    <a:bodyPr/>
+                    <a:lstStyle/>
+                    <a:p>
+                      <a:pPr algn="ctr"/>
+                      <a:r>
+                        <a:rPr lang="en-CN" sz="1500" b="1">
+                          <a:solidFill>
+                            <a:srgbClr val="FFFFFF"/>
+                          </a:solidFill>
+                        </a:rPr>
+                        <a:t>Large model (LLM)</a:t>
+                      </a:r>
+                    </a:p>
+                  </a:txBody>
+                  <a:tcPr anchor="ctr">
+                    <a:solidFill>
+                      <a:srgbClr val="00396B"/>
+                    </a:solidFill>
+                  </a:tcPr>
+                </a:tc>
+                <a:tc>
+                  <a:txBody>
+                    <a:bodyPr/>
+                    <a:lstStyle/>
+                    <a:p>
+                      <a:pPr algn="ctr"/>
+                      <a:r>
+                        <a:rPr lang="en-CN" sz="1500" b="1">
+                          <a:solidFill>
+                            <a:srgbClr val="FFFFFF"/>
+                          </a:solidFill>
+                        </a:rPr>
+                        <a:t>Small model (SLM)</a:t>
+                      </a:r>
+                    </a:p>
+                  </a:txBody>
+                  <a:tcPr anchor="ctr">
+                    <a:solidFill>
+                      <a:srgbClr val="00396B"/>
+                    </a:solidFill>
+                  </a:tcPr>
+                </a:tc>
+                <a:extLst>
+                  <a:ext uri="{0D108BD9-81ED-4DB2-BD59-A6C34878D82A}">
+                    <a16:rowId xmlns:a16="http://schemas.microsoft.com/office/drawing/2014/main" val="698580651"/>
+                  </a:ext>
+                </a:extLst>
+              </a:tr>
+              <a:tr h="355600">
+                <a:tc>
+                  <a:txBody>
+                    <a:bodyPr/>
+                    <a:lstStyle/>
+                    <a:p>
+                      <a:pPr algn="l"/>
+                      <a:r>
+                        <a:rPr lang="en-CN" sz="1400" b="1">
+                          <a:solidFill>
+                            <a:srgbClr val="00396B"/>
+                          </a:solidFill>
+                        </a:rPr>
+                        <a:t>Role</a:t>
+                      </a:r>
+                    </a:p>
+                  </a:txBody>
+                  <a:tcPr anchor="ctr">
+                    <a:solidFill>
+                      <a:srgbClr val="EEF2F6"/>
+                    </a:solidFill>
+                  </a:tcPr>
+                </a:tc>
+                <a:tc>
+                  <a:txBody>
+                    <a:bodyPr/>
+                    <a:lstStyle/>
+                    <a:p>
+                      <a:pPr algn="l"/>
+                      <a:r>
+                        <a:rPr lang="en-CN" sz="1400">
+                          <a:solidFill>
+                            <a:srgbClr val="1A1A1A"/>
+                          </a:solidFill>
+                        </a:rPr>
+                        <a:t>Planner / orchestrator</a:t>
+                      </a:r>
+                    </a:p>
+                  </a:txBody>
+                  <a:tcPr anchor="ctr">
+                    <a:solidFill>
+                      <a:srgbClr val="FFFFFF"/>
+                    </a:solidFill>
+                  </a:tcPr>
+                </a:tc>
+                <a:tc>
+                  <a:txBody>
+                    <a:bodyPr/>
+                    <a:lstStyle/>
+                    <a:p>
+                      <a:pPr algn="l"/>
+                      <a:r>
+                        <a:rPr lang="en-CN" sz="1400">
+                          <a:solidFill>
+                            <a:srgbClr val="1A1A1A"/>
+                          </a:solidFill>
+                        </a:rPr>
+                        <a:t>Executor / specialist</a:t>
+                      </a:r>
+                    </a:p>
+                  </a:txBody>
+                  <a:tcPr anchor="ctr">
+                    <a:solidFill>
+                      <a:srgbClr val="FFFFFF"/>
+                    </a:solidFill>
+                  </a:tcPr>
+                </a:tc>
+                <a:extLst>
+                  <a:ext uri="{0D108BD9-81ED-4DB2-BD59-A6C34878D82A}">
+                    <a16:rowId xmlns:a16="http://schemas.microsoft.com/office/drawing/2014/main" val="4037059216"/>
+                  </a:ext>
+                </a:extLst>
+              </a:tr>
+              <a:tr h="355600">
+                <a:tc>
+                  <a:txBody>
+                    <a:bodyPr/>
+                    <a:lstStyle/>
+                    <a:p>
+                      <a:pPr algn="l"/>
+                      <a:r>
+                        <a:rPr lang="en-CN" sz="1400" b="1">
+                          <a:solidFill>
+                            <a:srgbClr val="00396B"/>
+                          </a:solidFill>
+                        </a:rPr>
+                        <a:t>Handles</a:t>
+                      </a:r>
+                    </a:p>
+                  </a:txBody>
+                  <a:tcPr anchor="ctr">
+                    <a:solidFill>
+                      <a:srgbClr val="EEF2F6"/>
+                    </a:solidFill>
+                  </a:tcPr>
+                </a:tc>
+                <a:tc>
+                  <a:txBody>
+                    <a:bodyPr/>
+                    <a:lstStyle/>
+                    <a:p>
+                      <a:pPr algn="l"/>
+                      <a:r>
+                        <a:rPr lang="en-CN" sz="1400">
+                          <a:solidFill>
+                            <a:srgbClr val="1A1A1A"/>
+                          </a:solidFill>
+                        </a:rPr>
+                        <a:t>Complex reasoning, decomposition</a:t>
+                      </a:r>
+                    </a:p>
+                  </a:txBody>
+                  <a:tcPr anchor="ctr">
+                    <a:solidFill>
+                      <a:srgbClr val="FFFFFF"/>
+                    </a:solidFill>
+                  </a:tcPr>
+                </a:tc>
+                <a:tc>
+                  <a:txBody>
+                    <a:bodyPr/>
+                    <a:lstStyle/>
+                    <a:p>
+                      <a:pPr algn="l"/>
+                      <a:r>
+                        <a:rPr lang="en-CN" sz="1400">
+                          <a:solidFill>
+                            <a:srgbClr val="1A1A1A"/>
+                          </a:solidFill>
+                        </a:rPr>
+                        <a:t>Routine, latency-sensitive subtasks</a:t>
+                      </a:r>
+                    </a:p>
+                  </a:txBody>
+                  <a:tcPr anchor="ctr">
+                    <a:solidFill>
+                      <a:srgbClr val="FFFFFF"/>
+                    </a:solidFill>
+                  </a:tcPr>
+                </a:tc>
+                <a:extLst>
+                  <a:ext uri="{0D108BD9-81ED-4DB2-BD59-A6C34878D82A}">
+                    <a16:rowId xmlns:a16="http://schemas.microsoft.com/office/drawing/2014/main" val="2966796175"/>
+                  </a:ext>
+                </a:extLst>
+              </a:tr>
+              <a:tr h="355600">
+                <a:tc>
+                  <a:txBody>
+                    <a:bodyPr/>
+                    <a:lstStyle/>
+                    <a:p>
+                      <a:pPr algn="l"/>
+                      <a:r>
+                        <a:rPr lang="en-CN" sz="1400" b="1" dirty="0">
+                          <a:solidFill>
+                            <a:srgbClr val="00396B"/>
+                          </a:solidFill>
+                        </a:rPr>
+                        <a:t>Cost</a:t>
+                      </a:r>
+                      <a:r>
+                        <a:rPr lang="en-US" altLang="zh-CN" sz="1400" b="1" dirty="0">
+                          <a:solidFill>
+                            <a:srgbClr val="00396B"/>
+                          </a:solidFill>
+                        </a:rPr>
+                        <a:t>/Latency</a:t>
+                      </a:r>
+                      <a:endParaRPr lang="en-CN" sz="1400" b="1" dirty="0">
+                        <a:solidFill>
+                          <a:srgbClr val="00396B"/>
+                        </a:solidFill>
+                      </a:endParaRPr>
+                    </a:p>
+                  </a:txBody>
+                  <a:tcPr anchor="ctr">
+                    <a:solidFill>
+                      <a:srgbClr val="EEF2F6"/>
+                    </a:solidFill>
+                  </a:tcPr>
+                </a:tc>
+                <a:tc>
+                  <a:txBody>
+                    <a:bodyPr/>
+                    <a:lstStyle/>
+                    <a:p>
+                      <a:pPr algn="l"/>
+                      <a:r>
+                        <a:rPr lang="en-CN" sz="1400" b="1" dirty="0">
+                          <a:solidFill>
+                            <a:srgbClr val="00396B"/>
+                          </a:solidFill>
+                        </a:rPr>
+                        <a:t>High</a:t>
+                      </a:r>
+                    </a:p>
+                  </a:txBody>
+                  <a:tcPr anchor="ctr">
+                    <a:solidFill>
+                      <a:srgbClr val="FFFFFF"/>
+                    </a:solidFill>
+                  </a:tcPr>
+                </a:tc>
+                <a:tc>
+                  <a:txBody>
+                    <a:bodyPr/>
+                    <a:lstStyle/>
+                    <a:p>
+                      <a:pPr algn="l"/>
+                      <a:r>
+                        <a:rPr lang="en-CN" sz="1400" b="1" dirty="0">
+                          <a:solidFill>
+                            <a:srgbClr val="0073CF"/>
+                          </a:solidFill>
+                        </a:rPr>
+                        <a:t>Low</a:t>
+                      </a:r>
+                    </a:p>
+                  </a:txBody>
+                  <a:tcPr anchor="ctr">
+                    <a:solidFill>
+                      <a:srgbClr val="FFFFFF"/>
+                    </a:solidFill>
+                  </a:tcPr>
+                </a:tc>
+                <a:extLst>
+                  <a:ext uri="{0D108BD9-81ED-4DB2-BD59-A6C34878D82A}">
+                    <a16:rowId xmlns:a16="http://schemas.microsoft.com/office/drawing/2014/main" val="3661423708"/>
+                  </a:ext>
+                </a:extLst>
+              </a:tr>
+            </a:tbl>
+          </a:graphicData>
+        </a:graphic>
+      </p:graphicFrame>
+      <p:sp>
+        <p:nvSpPr>
+          <p:cNvPr id="11" name="Bilevel Box">
+            <a:extLst>
+              <a:ext uri="{FF2B5EF4-FFF2-40B4-BE49-F238E27FC236}">
+                <a16:creationId xmlns:a16="http://schemas.microsoft.com/office/drawing/2014/main" id="{BA0E625F-F202-264B-8D4C-2991FD6B7B63}"/>
+              </a:ext>
+            </a:extLst>
+          </p:cNvPr>
+          <p:cNvSpPr txBox="1"/>
+          <p:nvPr/>
+        </p:nvSpPr>
+        <p:spPr>
+          <a:xfrm>
+            <a:off x="838200" y="4572000"/>
+            <a:ext cx="10515600" cy="1676400"/>
+          </a:xfrm>
+          <a:prstGeom prst="rect">
+            <a:avLst/>
+          </a:prstGeom>
+          <a:noFill/>
+        </p:spPr>
+        <p:txBody>
+          <a:bodyPr vertOverflow="overflow" vert="horz" wrap="square" rtlCol="0" anchor="t">
+            <a:noAutofit/>
+          </a:bodyPr>
+          <a:lstStyle/>
+          <a:p>
+            <a:pPr marL="0" indent="0" algn="l">
+              <a:spcBef>
+                <a:spcPts val="0"/>
+              </a:spcBef>
+              <a:spcAft>
+                <a:spcPts val="200"/>
+              </a:spcAft>
+              <a:buNone/>
+            </a:pPr>
+            <a:r>
+              <a:rPr lang="en-US" sz="1800" b="1" dirty="0">
+                <a:solidFill>
+                  <a:srgbClr val="00396B"/>
+                </a:solidFill>
+              </a:rPr>
+              <a:t>Bilevel Collaboration</a:t>
+            </a:r>
+          </a:p>
+          <a:p>
+            <a:pPr marL="285750" indent="-285750" algn="l">
+              <a:spcBef>
+                <a:spcPts val="120"/>
+              </a:spcBef>
+              <a:spcAft>
+                <a:spcPts val="120"/>
+              </a:spcAft>
+              <a:buFont typeface="Arial"/>
+              <a:buChar char="•"/>
+            </a:pPr>
+            <a:r>
+              <a:rPr lang="en-US" sz="1500" b="1" dirty="0">
+                <a:solidFill>
+                  <a:srgbClr val="1A1A1A"/>
+                </a:solidFill>
+              </a:rPr>
+              <a:t>Task-level — cost-efficient: </a:t>
+            </a:r>
+            <a:r>
+              <a:rPr lang="en-US" sz="1500" dirty="0">
+                <a:solidFill>
+                  <a:srgbClr val="1A1A1A"/>
+                </a:solidFill>
+              </a:rPr>
+              <a:t>route simple subtasks to small models, sparing large-model calls.</a:t>
+            </a:r>
+          </a:p>
+          <a:p>
+            <a:pPr marL="285750" indent="-285750" algn="l">
+              <a:spcBef>
+                <a:spcPts val="120"/>
+              </a:spcBef>
+              <a:spcAft>
+                <a:spcPts val="200"/>
+              </a:spcAft>
+              <a:buFont typeface="Arial"/>
+              <a:buChar char="•"/>
+            </a:pPr>
+            <a:r>
+              <a:rPr lang="en-US" sz="1500" b="1" dirty="0">
+                <a:solidFill>
+                  <a:srgbClr val="1A1A1A"/>
+                </a:solidFill>
+              </a:rPr>
+              <a:t>Token-level — token-efficient: </a:t>
+            </a:r>
+            <a:r>
+              <a:rPr lang="en-US" sz="1500" dirty="0">
+                <a:solidFill>
+                  <a:srgbClr val="1A1A1A"/>
+                </a:solidFill>
+              </a:rPr>
+              <a:t>small models draft tokens via speculative decoding, verified in one pass.</a:t>
+            </a:r>
+          </a:p>
+          <a:p>
+            <a:pPr marL="0" indent="0" algn="l">
+              <a:spcBef>
+                <a:spcPts val="0"/>
+              </a:spcBef>
+              <a:spcAft>
+                <a:spcPts val="0"/>
+              </a:spcAft>
+              <a:buNone/>
+            </a:pPr>
+            <a:endParaRPr lang="en-US" sz="1500" b="1" i="1" dirty="0">
+              <a:solidFill>
+                <a:srgbClr val="0073CF"/>
+              </a:solidFill>
+            </a:endParaRPr>
+          </a:p>
+          <a:p>
+            <a:pPr marL="0" indent="0" algn="l">
+              <a:spcBef>
+                <a:spcPts val="0"/>
+              </a:spcBef>
+              <a:spcAft>
+                <a:spcPts val="0"/>
+              </a:spcAft>
+              <a:buNone/>
+            </a:pPr>
+            <a:r>
+              <a:rPr lang="en-US" sz="1500" b="1" i="1" dirty="0">
+                <a:solidFill>
+                  <a:srgbClr val="0073CF"/>
+                </a:solidFill>
+              </a:rPr>
+              <a:t>Unified, the two levels make end-to-end inference both cost- and token-efficient—without sacrificing quality.</a:t>
+            </a:r>
+          </a:p>
+        </p:txBody>
+      </p:sp>
+    </p:spTree>
+    <p:extLst>
+      <p:ext uri="{BB962C8B-B14F-4D97-AF65-F5344CB8AC3E}">
+        <p14:creationId xmlns:p14="http://schemas.microsoft.com/office/powerpoint/2010/main" val="2778514529"/>
+      </p:ext>
+    </p:extLst>
+  </p:cSld>
+  <p:clrMapOvr>
+    <a:masterClrMapping/>
+  </p:clrMapOvr>
+</p:sld>
+</file>
+
+<file path=ppt/slides/slide4.xml><?xml version="1.0" encoding="utf-8"?>
+<p:sld xmlns:a="http://schemas.openxmlformats.org/drawingml/2006/main" xmlns:r="http://schemas.openxmlformats.org/officeDocument/2006/relationships" xmlns:p="http://schemas.openxmlformats.org/presentationml/2006/main">
+  <p:cSld>
+    <p:spTree>
+      <p:nvGrpSpPr>
+        <p:cNvPr id="1" name="">
+          <a:extLst>
+            <a:ext uri="{FF2B5EF4-FFF2-40B4-BE49-F238E27FC236}">
+              <a16:creationId xmlns:a16="http://schemas.microsoft.com/office/drawing/2014/main" id="{D6062070-167E-3408-EEB2-F6ED38BCD5B7}"/>
+            </a:ext>
+          </a:extLst>
+        </p:cNvPr>
+        <p:cNvGrpSpPr/>
+        <p:nvPr/>
+      </p:nvGrpSpPr>
+      <p:grpSpPr>
+        <a:xfrm>
+          <a:off x="0" y="0"/>
+          <a:ext cx="0" cy="0"/>
+          <a:chOff x="0" y="0"/>
+          <a:chExt cx="0" cy="0"/>
+        </a:xfrm>
+      </p:grpSpPr>
+      <p:sp>
+        <p:nvSpPr>
+          <p:cNvPr id="5" name="Footer Bar">
+            <a:extLst>
+              <a:ext uri="{FF2B5EF4-FFF2-40B4-BE49-F238E27FC236}">
+                <a16:creationId xmlns:a16="http://schemas.microsoft.com/office/drawing/2014/main" id="{17037776-F042-D4D0-3477-67DA63A42406}"/>
+              </a:ext>
+            </a:extLst>
+          </p:cNvPr>
+          <p:cNvSpPr/>
+          <p:nvPr/>
+        </p:nvSpPr>
+        <p:spPr>
+          <a:xfrm>
+            <a:off x="0" y="6350000"/>
+            <a:ext cx="12192000" cy="508000"/>
+          </a:xfrm>
+          <a:prstGeom prst="rect">
+            <a:avLst/>
+          </a:prstGeom>
+          <a:solidFill>
+            <a:srgbClr val="00396B"/>
+          </a:solidFill>
+          <a:ln w="12700" cap="flat" cmpd="sng" algn="ctr">
+            <a:noFill/>
+            <a:prstDash val="solid"/>
+            <a:miter lim="800000"/>
+          </a:ln>
+        </p:spPr>
+        <p:style>
+          <a:lnRef idx="2">
+            <a:schemeClr val="accent1">
+              <a:shade val="15000"/>
+            </a:schemeClr>
+          </a:lnRef>
+          <a:fillRef idx="1">
+            <a:schemeClr val="accent1"/>
+          </a:fillRef>
+          <a:effectRef idx="0">
+            <a:schemeClr val="accent1"/>
+          </a:effectRef>
+          <a:fontRef idx="minor">
+            <a:schemeClr val="lt1"/>
+          </a:fontRef>
+        </p:style>
+        <p:txBody>
+          <a:bodyPr vertOverflow="clip" horzOverflow="clip" rtlCol="0" anchor="t"/>
+          <a:lstStyle/>
+          <a:p>
+            <a:pPr algn="l"/>
+            <a:endParaRPr lang="en-CN"/>
+          </a:p>
+        </p:txBody>
+      </p:sp>
+      <p:sp>
+        <p:nvSpPr>
+          <p:cNvPr id="2" name="Title 1">
+            <a:extLst>
+              <a:ext uri="{FF2B5EF4-FFF2-40B4-BE49-F238E27FC236}">
+                <a16:creationId xmlns:a16="http://schemas.microsoft.com/office/drawing/2014/main" id="{639BD462-E1DC-1CB9-A732-6BBF69942286}"/>
+              </a:ext>
+            </a:extLst>
+          </p:cNvPr>
+          <p:cNvSpPr>
+            <a:spLocks noGrp="1"/>
+          </p:cNvSpPr>
+          <p:nvPr>
+            <p:ph type="title"/>
+          </p:nvPr>
+        </p:nvSpPr>
+        <p:spPr>
+          <a:xfrm>
+            <a:off x="838200" y="1397000"/>
+            <a:ext cx="10515600" cy="711200"/>
+          </a:xfrm>
+        </p:spPr>
+        <p:txBody>
+          <a:bodyPr anchor="t" anchorCtr="0"/>
+          <a:lstStyle/>
+          <a:p>
+            <a:r>
+              <a:rPr lang="en-US" sz="3200" b="1" dirty="0">
+                <a:solidFill>
+                  <a:srgbClr val="00396B"/>
+                </a:solidFill>
+              </a:rPr>
+              <a:t>Project</a:t>
+            </a:r>
+            <a:r>
+              <a:rPr lang="zh-CN" altLang="en-US" sz="3200" b="1" dirty="0">
+                <a:solidFill>
+                  <a:srgbClr val="00396B"/>
+                </a:solidFill>
+              </a:rPr>
+              <a:t> </a:t>
+            </a:r>
+            <a:r>
+              <a:rPr lang="en-US" altLang="zh-CN" sz="3200" b="1" dirty="0">
+                <a:solidFill>
+                  <a:srgbClr val="00396B"/>
+                </a:solidFill>
+              </a:rPr>
+              <a:t>Plan</a:t>
+            </a:r>
+            <a:endParaRPr lang="en-US" sz="3200" b="1" dirty="0">
+              <a:solidFill>
+                <a:srgbClr val="00396B"/>
+              </a:solidFill>
+            </a:endParaRPr>
+          </a:p>
+        </p:txBody>
+      </p:sp>
+      <p:sp>
+        <p:nvSpPr>
+          <p:cNvPr id="3" name="Content Placeholder 2">
+            <a:extLst>
+              <a:ext uri="{FF2B5EF4-FFF2-40B4-BE49-F238E27FC236}">
+                <a16:creationId xmlns:a16="http://schemas.microsoft.com/office/drawing/2014/main" id="{8C0AF201-9B98-2B16-C7F0-1698DC08D7EA}"/>
+              </a:ext>
+            </a:extLst>
+          </p:cNvPr>
+          <p:cNvSpPr>
+            <a:spLocks noGrp="1"/>
+          </p:cNvSpPr>
+          <p:nvPr>
+            <p:ph idx="1"/>
+          </p:nvPr>
+        </p:nvSpPr>
+        <p:spPr>
+          <a:xfrm>
+            <a:off x="838200" y="2540000"/>
+            <a:ext cx="10515600" cy="3657600"/>
+          </a:xfrm>
+        </p:spPr>
+        <p:txBody>
+          <a:bodyPr>
+            <a:normAutofit/>
+          </a:bodyPr>
+          <a:lstStyle/>
+          <a:p>
+            <a:pPr marL="0" indent="0" algn="l">
+              <a:spcBef>
+                <a:spcPts val="300"/>
+              </a:spcBef>
+              <a:spcAft>
+                <a:spcPts val="300"/>
+              </a:spcAft>
+              <a:buNone/>
+            </a:pPr>
+            <a:r>
+              <a:rPr lang="en-US" sz="1900" b="1" dirty="0">
+                <a:solidFill>
+                  <a:srgbClr val="00396B"/>
+                </a:solidFill>
+              </a:rPr>
+              <a:t>Models</a:t>
+            </a:r>
+          </a:p>
+          <a:p>
+            <a:pPr marL="342900" indent="-342900" algn="l">
+              <a:spcBef>
+                <a:spcPts val="300"/>
+              </a:spcBef>
+              <a:spcAft>
+                <a:spcPts val="300"/>
+              </a:spcAft>
+              <a:buFont typeface="Arial"/>
+              <a:buChar char="•"/>
+            </a:pPr>
+            <a:r>
+              <a:rPr lang="en-US" sz="1600" b="1" dirty="0">
+                <a:solidFill>
+                  <a:srgbClr val="1A1A1A"/>
+                </a:solidFill>
+              </a:rPr>
+              <a:t>Closed-source (API): </a:t>
+            </a:r>
+            <a:r>
+              <a:rPr lang="en-US" sz="1600" dirty="0">
+                <a:solidFill>
+                  <a:srgbClr val="1A1A1A"/>
+                </a:solidFill>
+              </a:rPr>
+              <a:t>Claude</a:t>
+            </a:r>
+          </a:p>
+          <a:p>
+            <a:pPr marL="342900" indent="-342900" algn="l">
+              <a:spcBef>
+                <a:spcPts val="300"/>
+              </a:spcBef>
+              <a:spcAft>
+                <a:spcPts val="300"/>
+              </a:spcAft>
+              <a:buFont typeface="Arial"/>
+              <a:buChar char="•"/>
+            </a:pPr>
+            <a:r>
+              <a:rPr lang="en-US" sz="1600" b="1" dirty="0">
+                <a:solidFill>
+                  <a:srgbClr val="1A1A1A"/>
+                </a:solidFill>
+              </a:rPr>
+              <a:t>Open-source: </a:t>
+            </a:r>
+            <a:r>
+              <a:rPr lang="en-US" sz="1600" dirty="0">
+                <a:solidFill>
+                  <a:srgbClr val="1A1A1A"/>
+                </a:solidFill>
+              </a:rPr>
+              <a:t>Qwen series</a:t>
+            </a:r>
+          </a:p>
+          <a:p>
+            <a:pPr marL="0" indent="0" algn="l">
+              <a:spcBef>
+                <a:spcPts val="900"/>
+              </a:spcBef>
+              <a:spcAft>
+                <a:spcPts val="300"/>
+              </a:spcAft>
+              <a:buNone/>
+            </a:pPr>
+            <a:r>
+              <a:rPr lang="en-US" sz="1900" b="1" dirty="0">
+                <a:solidFill>
+                  <a:srgbClr val="00396B"/>
+                </a:solidFill>
+              </a:rPr>
+              <a:t>Tasks</a:t>
+            </a:r>
+          </a:p>
+          <a:p>
+            <a:pPr marL="342900" indent="-342900" algn="l">
+              <a:spcBef>
+                <a:spcPts val="300"/>
+              </a:spcBef>
+              <a:spcAft>
+                <a:spcPts val="300"/>
+              </a:spcAft>
+              <a:buFont typeface="Arial"/>
+              <a:buChar char="•"/>
+            </a:pPr>
+            <a:r>
+              <a:rPr lang="en-US" sz="1600" b="1" dirty="0">
+                <a:solidFill>
+                  <a:srgbClr val="1A1A1A"/>
+                </a:solidFill>
+              </a:rPr>
+              <a:t>Deep Search: </a:t>
+            </a:r>
+            <a:r>
+              <a:rPr lang="en-US" sz="1600" dirty="0">
+                <a:solidFill>
+                  <a:srgbClr val="1A1A1A"/>
+                </a:solidFill>
+              </a:rPr>
+              <a:t>multi-step retrieval across sources</a:t>
+            </a:r>
+          </a:p>
+          <a:p>
+            <a:pPr marL="342900" indent="-342900" algn="l">
+              <a:spcBef>
+                <a:spcPts val="300"/>
+              </a:spcBef>
+              <a:spcAft>
+                <a:spcPts val="300"/>
+              </a:spcAft>
+              <a:buFont typeface="Arial"/>
+              <a:buChar char="•"/>
+            </a:pPr>
+            <a:r>
+              <a:rPr lang="en-US" sz="1600" b="1" dirty="0">
+                <a:solidFill>
+                  <a:srgbClr val="1A1A1A"/>
+                </a:solidFill>
+              </a:rPr>
+              <a:t>Deep Research: </a:t>
+            </a:r>
+            <a:r>
+              <a:rPr lang="en-US" sz="1600" dirty="0">
+                <a:solidFill>
+                  <a:srgbClr val="1A1A1A"/>
+                </a:solidFill>
+              </a:rPr>
+              <a:t>synthesis of findings into structured reports</a:t>
+            </a:r>
+          </a:p>
+          <a:p>
+            <a:pPr marL="342900" indent="-342900" algn="l">
+              <a:spcBef>
+                <a:spcPts val="300"/>
+              </a:spcBef>
+              <a:spcAft>
+                <a:spcPts val="300"/>
+              </a:spcAft>
+              <a:buFont typeface="Arial"/>
+              <a:buChar char="•"/>
+            </a:pPr>
+            <a:r>
+              <a:rPr lang="en-US" sz="1600" b="1" dirty="0">
+                <a:solidFill>
+                  <a:srgbClr val="1A1A1A"/>
+                </a:solidFill>
+              </a:rPr>
+              <a:t>Code Generation: </a:t>
+            </a:r>
+            <a:r>
+              <a:rPr lang="en-US" sz="1600" dirty="0">
+                <a:solidFill>
+                  <a:srgbClr val="1A1A1A"/>
+                </a:solidFill>
+              </a:rPr>
+              <a:t>end-to-end code writing and execution</a:t>
+            </a:r>
+          </a:p>
+          <a:p>
+            <a:pPr marL="0" indent="0" algn="l">
+              <a:spcBef>
+                <a:spcPts val="900"/>
+              </a:spcBef>
+              <a:spcAft>
+                <a:spcPts val="300"/>
+              </a:spcAft>
+              <a:buNone/>
+            </a:pPr>
+            <a:r>
+              <a:rPr lang="en-US" sz="1900" b="1" dirty="0">
+                <a:solidFill>
+                  <a:srgbClr val="00396B"/>
+                </a:solidFill>
+              </a:rPr>
+              <a:t>Metrics</a:t>
+            </a:r>
+          </a:p>
+          <a:p>
+            <a:pPr marL="342900" indent="-342900" algn="l">
+              <a:spcBef>
+                <a:spcPts val="300"/>
+              </a:spcBef>
+              <a:spcAft>
+                <a:spcPts val="300"/>
+              </a:spcAft>
+              <a:buFont typeface="Arial"/>
+              <a:buChar char="•"/>
+            </a:pPr>
+            <a:r>
+              <a:rPr lang="en-US" sz="1600" b="1" dirty="0">
+                <a:solidFill>
+                  <a:srgbClr val="1A1A1A"/>
+                </a:solidFill>
+              </a:rPr>
+              <a:t>Quality: </a:t>
+            </a:r>
+            <a:r>
+              <a:rPr lang="en-US" sz="1600" dirty="0">
+                <a:solidFill>
+                  <a:srgbClr val="1A1A1A"/>
+                </a:solidFill>
+              </a:rPr>
+              <a:t>task accuracy and answer correctness</a:t>
+            </a:r>
+          </a:p>
+          <a:p>
+            <a:pPr marL="342900" indent="-342900" algn="l">
+              <a:spcBef>
+                <a:spcPts val="300"/>
+              </a:spcBef>
+              <a:spcAft>
+                <a:spcPts val="300"/>
+              </a:spcAft>
+              <a:buFont typeface="Arial"/>
+              <a:buChar char="•"/>
+            </a:pPr>
+            <a:r>
+              <a:rPr lang="en-US" sz="1600" b="1" dirty="0">
+                <a:solidFill>
+                  <a:srgbClr val="1A1A1A"/>
+                </a:solidFill>
+              </a:rPr>
+              <a:t>Efficiency: </a:t>
+            </a:r>
+            <a:r>
+              <a:rPr lang="en-US" sz="1600" dirty="0">
+                <a:solidFill>
+                  <a:srgbClr val="1A1A1A"/>
+                </a:solidFill>
+              </a:rPr>
+              <a:t>token cost and latency</a:t>
+            </a:r>
+          </a:p>
+        </p:txBody>
+      </p:sp>
+      <p:sp>
+        <p:nvSpPr>
+          <p:cNvPr id="4" name="Slide Number Placeholder 3">
+            <a:extLst>
+              <a:ext uri="{FF2B5EF4-FFF2-40B4-BE49-F238E27FC236}">
+                <a16:creationId xmlns:a16="http://schemas.microsoft.com/office/drawing/2014/main" id="{655AF0E1-99F5-B2B8-5864-40A0EC7866A0}"/>
+              </a:ext>
+            </a:extLst>
+          </p:cNvPr>
+          <p:cNvSpPr>
+            <a:spLocks noGrp="1"/>
+          </p:cNvSpPr>
+          <p:nvPr>
+            <p:ph type="sldNum" sz="quarter" idx="12"/>
+          </p:nvPr>
+        </p:nvSpPr>
+        <p:spPr>
+          <a:xfrm>
+            <a:off x="10210800" y="6451600"/>
+            <a:ext cx="1524000" cy="304800"/>
+          </a:xfrm>
+        </p:spPr>
+        <p:txBody>
+          <a:bodyPr anchor="ctr" anchorCtr="0"/>
+          <a:lstStyle/>
+          <a:p>
+            <a:fld id="{FC0A7A6B-4B1F-5446-A3A1-99DEB5EA7F81}" type="slidenum">
+              <a:rPr lang="en-CN" smtClean="0">
+                <a:solidFill>
+                  <a:srgbClr val="9AA7B5"/>
+                </a:solidFill>
+              </a:rPr>
+              <a:t>4</a:t>
+            </a:fld>
+            <a:endParaRPr lang="en-CN">
+              <a:solidFill>
+                <a:srgbClr val="9AA7B5"/>
+              </a:solidFill>
+            </a:endParaRPr>
+          </a:p>
+        </p:txBody>
+      </p:sp>
+      <p:sp>
+        <p:nvSpPr>
+          <p:cNvPr id="6" name="Accent Rule">
+            <a:extLst>
+              <a:ext uri="{FF2B5EF4-FFF2-40B4-BE49-F238E27FC236}">
+                <a16:creationId xmlns:a16="http://schemas.microsoft.com/office/drawing/2014/main" id="{1FEDF0BE-EA3E-F678-521A-F662C53C156B}"/>
+              </a:ext>
+            </a:extLst>
+          </p:cNvPr>
+          <p:cNvSpPr/>
+          <p:nvPr/>
+        </p:nvSpPr>
+        <p:spPr>
+          <a:xfrm>
+            <a:off x="838200" y="2209800"/>
+            <a:ext cx="1524000" cy="76200"/>
+          </a:xfrm>
+          <a:prstGeom prst="rect">
+            <a:avLst/>
+          </a:prstGeom>
+          <a:solidFill>
+            <a:srgbClr val="0073CF"/>
+          </a:solidFill>
+          <a:ln w="12700" cap="flat" cmpd="sng" algn="ctr">
+            <a:noFill/>
+            <a:prstDash val="solid"/>
+            <a:miter lim="800000"/>
+          </a:ln>
+        </p:spPr>
+        <p:style>
+          <a:lnRef idx="2">
+            <a:schemeClr val="accent1">
+              <a:shade val="15000"/>
+            </a:schemeClr>
+          </a:lnRef>
+          <a:fillRef idx="1">
+            <a:schemeClr val="accent1"/>
+          </a:fillRef>
+          <a:effectRef idx="0">
+            <a:schemeClr val="accent1"/>
+          </a:effectRef>
+          <a:fontRef idx="minor">
+            <a:schemeClr val="lt1"/>
+          </a:fontRef>
+        </p:style>
+        <p:txBody>
+          <a:bodyPr vertOverflow="clip" horzOverflow="clip" rtlCol="0" anchor="t"/>
+          <a:lstStyle/>
+          <a:p>
+            <a:pPr algn="l"/>
+            <a:endParaRPr lang="en-CN"/>
+          </a:p>
+        </p:txBody>
+      </p:sp>
+      <p:pic>
+        <p:nvPicPr>
+          <p:cNvPr id="7" name="Copied Picture 7">
+            <a:extLst>
+              <a:ext uri="{FF2B5EF4-FFF2-40B4-BE49-F238E27FC236}">
+                <a16:creationId xmlns:a16="http://schemas.microsoft.com/office/drawing/2014/main" id="{00348D28-ADBA-B423-2122-472CBF1EF219}"/>
+              </a:ext>
+            </a:extLst>
+          </p:cNvPr>
+          <p:cNvPicPr>
+            <a:picLocks noChangeAspect="1"/>
+          </p:cNvPicPr>
+          <p:nvPr/>
+        </p:nvPicPr>
+        <p:blipFill>
+          <a:blip r:embed="rId2"/>
+          <a:stretch>
+            <a:fillRect/>
+          </a:stretch>
+        </p:blipFill>
+        <p:spPr>
+          <a:xfrm>
+            <a:off x="838200" y="508000"/>
+            <a:ext cx="762000" cy="762000"/>
+          </a:xfrm>
+          <a:prstGeom prst="rect">
+            <a:avLst/>
+          </a:prstGeom>
+        </p:spPr>
+      </p:pic>
+      <p:sp>
+        <p:nvSpPr>
+          <p:cNvPr id="10" name="Footer Name">
+            <a:extLst>
+              <a:ext uri="{FF2B5EF4-FFF2-40B4-BE49-F238E27FC236}">
+                <a16:creationId xmlns:a16="http://schemas.microsoft.com/office/drawing/2014/main" id="{BEEE8946-DC29-629D-73C8-6B761EF36F3D}"/>
+              </a:ext>
+            </a:extLst>
+          </p:cNvPr>
+          <p:cNvSpPr txBox="1"/>
+          <p:nvPr/>
+        </p:nvSpPr>
+        <p:spPr>
+          <a:xfrm>
+            <a:off x="838200" y="6350000"/>
+            <a:ext cx="5080000" cy="508000"/>
+          </a:xfrm>
+          <a:prstGeom prst="rect">
+            <a:avLst/>
+          </a:prstGeom>
+          <a:noFill/>
+        </p:spPr>
+        <p:txBody>
+          <a:bodyPr vertOverflow="overflow" vert="horz" wrap="none" rtlCol="0" anchor="ctr" anchorCtr="0">
+            <a:noAutofit/>
+          </a:bodyPr>
+          <a:lstStyle/>
+          <a:p>
+            <a:pPr algn="l">
+              <a:buNone/>
+            </a:pPr>
+            <a:r>
+              <a:rPr lang="en-US" sz="1400" b="1" spc="200" dirty="0">
+                <a:solidFill>
+                  <a:srgbClr val="FFFFFF"/>
+                </a:solidFill>
+              </a:rPr>
+              <a:t>Quan Wei</a:t>
+            </a:r>
+            <a:r>
+              <a:rPr lang="en-US" sz="1400" b="1" spc="200" dirty="0">
+                <a:solidFill>
+                  <a:srgbClr val="9AA7B5"/>
+                </a:solidFill>
+              </a:rPr>
+              <a:t>   |   </a:t>
+            </a:r>
+            <a:r>
+              <a:rPr lang="en-US" sz="1400" b="1" spc="200" dirty="0">
+                <a:solidFill>
+                  <a:srgbClr val="FFFFFF"/>
+                </a:solidFill>
+              </a:rPr>
+              <a:t>WEEK 1</a:t>
+            </a:r>
+          </a:p>
+        </p:txBody>
+      </p:sp>
+    </p:spTree>
+    <p:extLst>
+      <p:ext uri="{BB962C8B-B14F-4D97-AF65-F5344CB8AC3E}">
+        <p14:creationId xmlns:p14="http://schemas.microsoft.com/office/powerpoint/2010/main" val="1557384389"/>
+      </p:ext>
+    </p:extLst>
+  </p:cSld>
+  <p:clrMapOvr>
+    <a:masterClrMapping/>
+  </p:clrMapOvr>
+</p:sld>
+</file>
+
+<file path=ppt/slides/slide5.xml><?xml version="1.0" encoding="utf-8"?>
+<p:sld xmlns:a="http://schemas.openxmlformats.org/drawingml/2006/main" xmlns:r="http://schemas.openxmlformats.org/officeDocument/2006/relationships" xmlns:p="http://schemas.openxmlformats.org/presentationml/2006/main">
+  <p:cSld>
+    <p:spTree>
+      <p:nvGrpSpPr>
+        <p:cNvPr id="1" name="">
+          <a:extLst>
+            <a:ext uri="{FF2B5EF4-FFF2-40B4-BE49-F238E27FC236}">
+              <a16:creationId xmlns:a16="http://schemas.microsoft.com/office/drawing/2014/main" id="{C17FF716-6B78-A664-4C46-3C5977ECDDBA}"/>
+            </a:ext>
+          </a:extLst>
+        </p:cNvPr>
+        <p:cNvGrpSpPr/>
+        <p:nvPr/>
+      </p:nvGrpSpPr>
+      <p:grpSpPr>
+        <a:xfrm>
+          <a:off x="0" y="0"/>
+          <a:ext cx="0" cy="0"/>
+          <a:chOff x="0" y="0"/>
+          <a:chExt cx="0" cy="0"/>
+        </a:xfrm>
+      </p:grpSpPr>
+      <p:sp>
+        <p:nvSpPr>
+          <p:cNvPr id="5" name="Footer Bar">
+            <a:extLst>
+              <a:ext uri="{FF2B5EF4-FFF2-40B4-BE49-F238E27FC236}">
+                <a16:creationId xmlns:a16="http://schemas.microsoft.com/office/drawing/2014/main" id="{3C9D4CEF-3555-7854-1F9D-D28008C4F266}"/>
+              </a:ext>
+            </a:extLst>
+          </p:cNvPr>
+          <p:cNvSpPr/>
+          <p:nvPr/>
+        </p:nvSpPr>
+        <p:spPr>
+          <a:xfrm>
+            <a:off x="0" y="6350000"/>
+            <a:ext cx="12192000" cy="508000"/>
+          </a:xfrm>
+          <a:prstGeom prst="rect">
+            <a:avLst/>
+          </a:prstGeom>
+          <a:solidFill>
+            <a:srgbClr val="00396B"/>
+          </a:solidFill>
+          <a:ln w="12700" cap="flat" cmpd="sng" algn="ctr">
+            <a:noFill/>
+            <a:prstDash val="solid"/>
+            <a:miter lim="800000"/>
+          </a:ln>
+        </p:spPr>
+        <p:style>
+          <a:lnRef idx="2">
+            <a:schemeClr val="accent1">
+              <a:shade val="15000"/>
+            </a:schemeClr>
+          </a:lnRef>
+          <a:fillRef idx="1">
+            <a:schemeClr val="accent1"/>
+          </a:fillRef>
+          <a:effectRef idx="0">
+            <a:schemeClr val="accent1"/>
+          </a:effectRef>
+          <a:fontRef idx="minor">
+            <a:schemeClr val="lt1"/>
+          </a:fontRef>
+        </p:style>
+        <p:txBody>
+          <a:bodyPr vertOverflow="clip" horzOverflow="clip" rtlCol="0" anchor="t"/>
+          <a:lstStyle/>
+          <a:p>
+            <a:pPr algn="l"/>
+            <a:endParaRPr lang="en-CN"/>
+          </a:p>
+        </p:txBody>
+      </p:sp>
+      <p:sp>
+        <p:nvSpPr>
+          <p:cNvPr id="2" name="Title 1">
+            <a:extLst>
+              <a:ext uri="{FF2B5EF4-FFF2-40B4-BE49-F238E27FC236}">
+                <a16:creationId xmlns:a16="http://schemas.microsoft.com/office/drawing/2014/main" id="{F0B634FB-DF64-3844-36D2-1830F63A78A5}"/>
+              </a:ext>
+            </a:extLst>
+          </p:cNvPr>
+          <p:cNvSpPr>
+            <a:spLocks noGrp="1"/>
+          </p:cNvSpPr>
+          <p:nvPr>
+            <p:ph type="title"/>
+          </p:nvPr>
+        </p:nvSpPr>
+        <p:spPr>
+          <a:xfrm>
+            <a:off x="838200" y="1397000"/>
+            <a:ext cx="10515600" cy="711200"/>
+          </a:xfrm>
+        </p:spPr>
+        <p:txBody>
+          <a:bodyPr anchor="t" anchorCtr="0"/>
+          <a:lstStyle/>
+          <a:p>
+            <a:endParaRPr lang="en-US" sz="3200" b="1" dirty="0">
+              <a:solidFill>
+                <a:srgbClr val="00396B"/>
+              </a:solidFill>
+            </a:endParaRPr>
+          </a:p>
+        </p:txBody>
+      </p:sp>
+      <p:sp>
+        <p:nvSpPr>
+          <p:cNvPr id="3" name="Content Placeholder 2">
+            <a:extLst>
+              <a:ext uri="{FF2B5EF4-FFF2-40B4-BE49-F238E27FC236}">
+                <a16:creationId xmlns:a16="http://schemas.microsoft.com/office/drawing/2014/main" id="{F36A2116-23F5-FE71-A642-B53DB8E4A88E}"/>
+              </a:ext>
+            </a:extLst>
+          </p:cNvPr>
+          <p:cNvSpPr>
+            <a:spLocks noGrp="1"/>
+          </p:cNvSpPr>
+          <p:nvPr>
+            <p:ph idx="1"/>
+          </p:nvPr>
+        </p:nvSpPr>
+        <p:spPr>
+          <a:xfrm>
+            <a:off x="838200" y="2540000"/>
+            <a:ext cx="10515600" cy="3657600"/>
+          </a:xfrm>
+        </p:spPr>
+        <p:txBody>
+          <a:bodyPr>
+            <a:normAutofit/>
+          </a:bodyPr>
+          <a:lstStyle/>
+          <a:p>
+            <a:pPr marL="0" indent="0" algn="l">
+              <a:spcBef>
+                <a:spcPts val="100"/>
+              </a:spcBef>
+              <a:spcAft>
+                <a:spcPts val="150"/>
+              </a:spcAft>
+              <a:buNone/>
+            </a:pPr>
+            <a:endParaRPr lang="en-US" sz="1500" dirty="0">
+              <a:solidFill>
+                <a:srgbClr val="0073CF"/>
+              </a:solidFill>
+            </a:endParaRPr>
+          </a:p>
+        </p:txBody>
+      </p:sp>
+      <p:sp>
+        <p:nvSpPr>
+          <p:cNvPr id="4" name="Slide Number Placeholder 3">
+            <a:extLst>
+              <a:ext uri="{FF2B5EF4-FFF2-40B4-BE49-F238E27FC236}">
+                <a16:creationId xmlns:a16="http://schemas.microsoft.com/office/drawing/2014/main" id="{F4266C49-890C-B537-243D-F46EA0E6AA60}"/>
+              </a:ext>
+            </a:extLst>
+          </p:cNvPr>
+          <p:cNvSpPr>
+            <a:spLocks noGrp="1"/>
+          </p:cNvSpPr>
+          <p:nvPr>
+            <p:ph type="sldNum" sz="quarter" idx="12"/>
+          </p:nvPr>
+        </p:nvSpPr>
+        <p:spPr>
+          <a:xfrm>
+            <a:off x="10210800" y="6451600"/>
+            <a:ext cx="1524000" cy="304800"/>
+          </a:xfrm>
+        </p:spPr>
+        <p:txBody>
+          <a:bodyPr anchor="ctr" anchorCtr="0"/>
+          <a:lstStyle/>
+          <a:p>
+            <a:fld id="{FC0A7A6B-4B1F-5446-A3A1-99DEB5EA7F81}" type="slidenum">
+              <a:rPr lang="en-CN" smtClean="0">
+                <a:solidFill>
+                  <a:srgbClr val="9AA7B5"/>
+                </a:solidFill>
+              </a:rPr>
+              <a:t>5</a:t>
+            </a:fld>
+            <a:endParaRPr lang="en-CN">
+              <a:solidFill>
+                <a:srgbClr val="9AA7B5"/>
+              </a:solidFill>
+            </a:endParaRPr>
+          </a:p>
+        </p:txBody>
+      </p:sp>
+      <p:sp>
+        <p:nvSpPr>
+          <p:cNvPr id="6" name="Accent Rule">
+            <a:extLst>
+              <a:ext uri="{FF2B5EF4-FFF2-40B4-BE49-F238E27FC236}">
+                <a16:creationId xmlns:a16="http://schemas.microsoft.com/office/drawing/2014/main" id="{F552D167-F6C6-DD8A-C58A-E3062CB80615}"/>
+              </a:ext>
+            </a:extLst>
+          </p:cNvPr>
+          <p:cNvSpPr/>
+          <p:nvPr/>
+        </p:nvSpPr>
+        <p:spPr>
+          <a:xfrm>
+            <a:off x="838200" y="2209800"/>
+            <a:ext cx="1524000" cy="76200"/>
+          </a:xfrm>
+          <a:prstGeom prst="rect">
+            <a:avLst/>
+          </a:prstGeom>
+          <a:solidFill>
+            <a:srgbClr val="0073CF"/>
+          </a:solidFill>
+          <a:ln w="12700" cap="flat" cmpd="sng" algn="ctr">
+            <a:noFill/>
+            <a:prstDash val="solid"/>
+            <a:miter lim="800000"/>
+          </a:ln>
+        </p:spPr>
+        <p:style>
+          <a:lnRef idx="2">
+            <a:schemeClr val="accent1">
+              <a:shade val="15000"/>
+            </a:schemeClr>
+          </a:lnRef>
+          <a:fillRef idx="1">
+            <a:schemeClr val="accent1"/>
+          </a:fillRef>
+          <a:effectRef idx="0">
+            <a:schemeClr val="accent1"/>
+          </a:effectRef>
+          <a:fontRef idx="minor">
+            <a:schemeClr val="lt1"/>
+          </a:fontRef>
+        </p:style>
+        <p:txBody>
+          <a:bodyPr vertOverflow="clip" horzOverflow="clip" rtlCol="0" anchor="t"/>
+          <a:lstStyle/>
+          <a:p>
+            <a:pPr algn="l"/>
+            <a:endParaRPr lang="en-CN"/>
+          </a:p>
+        </p:txBody>
+      </p:sp>
+      <p:pic>
+        <p:nvPicPr>
+          <p:cNvPr id="7" name="Copied Picture 7">
+            <a:extLst>
+              <a:ext uri="{FF2B5EF4-FFF2-40B4-BE49-F238E27FC236}">
+                <a16:creationId xmlns:a16="http://schemas.microsoft.com/office/drawing/2014/main" id="{44F6969E-B7D6-DB4F-3D46-0898E523108E}"/>
+              </a:ext>
+            </a:extLst>
+          </p:cNvPr>
+          <p:cNvPicPr>
+            <a:picLocks noChangeAspect="1"/>
+          </p:cNvPicPr>
+          <p:nvPr/>
+        </p:nvPicPr>
+        <p:blipFill>
+          <a:blip r:embed="rId2"/>
+          <a:stretch>
+            <a:fillRect/>
+          </a:stretch>
+        </p:blipFill>
+        <p:spPr>
+          <a:xfrm>
+            <a:off x="838200" y="508000"/>
+            <a:ext cx="762000" cy="762000"/>
+          </a:xfrm>
+          <a:prstGeom prst="rect">
+            <a:avLst/>
+          </a:prstGeom>
+        </p:spPr>
+      </p:pic>
+      <p:sp>
+        <p:nvSpPr>
+          <p:cNvPr id="10" name="Footer Name">
+            <a:extLst>
+              <a:ext uri="{FF2B5EF4-FFF2-40B4-BE49-F238E27FC236}">
+                <a16:creationId xmlns:a16="http://schemas.microsoft.com/office/drawing/2014/main" id="{5640A57E-3A3F-4D74-E8E3-76F0EFD6D3B0}"/>
+              </a:ext>
+            </a:extLst>
+          </p:cNvPr>
+          <p:cNvSpPr txBox="1"/>
+          <p:nvPr/>
+        </p:nvSpPr>
+        <p:spPr>
+          <a:xfrm>
+            <a:off x="838200" y="6350000"/>
+            <a:ext cx="5080000" cy="508000"/>
+          </a:xfrm>
+          <a:prstGeom prst="rect">
+            <a:avLst/>
+          </a:prstGeom>
+          <a:noFill/>
+        </p:spPr>
+        <p:txBody>
+          <a:bodyPr vertOverflow="overflow" vert="horz" wrap="none" rtlCol="0" anchor="ctr" anchorCtr="0">
+            <a:noAutofit/>
+          </a:bodyPr>
+          <a:lstStyle/>
+          <a:p>
+            <a:pPr algn="l">
+              <a:buNone/>
+            </a:pPr>
+            <a:r>
+              <a:rPr lang="en-US" sz="1400" b="1" spc="200" dirty="0">
+                <a:solidFill>
+                  <a:srgbClr val="FFFFFF"/>
+                </a:solidFill>
+              </a:rPr>
+              <a:t>Quan Wei</a:t>
+            </a:r>
+            <a:r>
+              <a:rPr lang="en-US" sz="1400" b="1" spc="200" dirty="0">
+                <a:solidFill>
+                  <a:srgbClr val="9AA7B5"/>
+                </a:solidFill>
+              </a:rPr>
+              <a:t>   |   </a:t>
+            </a:r>
+            <a:r>
+              <a:rPr lang="en-US" sz="1400" b="1" spc="200" dirty="0">
+                <a:solidFill>
+                  <a:srgbClr val="FFFFFF"/>
+                </a:solidFill>
+              </a:rPr>
+              <a:t>WEEK 1</a:t>
+            </a:r>
+          </a:p>
+        </p:txBody>
+      </p:sp>
+    </p:spTree>
+    <p:extLst>
+      <p:ext uri="{BB962C8B-B14F-4D97-AF65-F5344CB8AC3E}">
+        <p14:creationId xmlns:p14="http://schemas.microsoft.com/office/powerpoint/2010/main" val="3498725614"/>
       </p:ext>
     </p:extLst>
   </p:cSld>

</xml_diff>